<commit_message>
Simplify Module 8 deck, add DSPy bridge slides and demo 1b
- Rework Module 8 deck: less text per slide, detail moved to speaker notes,
  six new conceptual slides for first-time DSPy users; keep original as backup
- Remove PowerPoint sections from Module 7 and 8 decks
- Add demo 1b: multi-field extraction and inline string Signatures

Co-Authored-By: Claude Opus 5.5 <noreply@anthropic.com>
</commit_message>
<xml_diff>
--- a/Module7_Demo_v1.0/Module7_Structured_Outputs_Function_Calling_and_Tool_Use.pptx
+++ b/Module7_Demo_v1.0/Module7_Structured_Outputs_Function_Calling_and_Tool_Use.pptx
@@ -122,52 +122,6 @@
     </a:lvl9pPr>
   </p:defaultTextStyle>
   <p:extLst>
-    <p:ext uri="{521415D9-36F7-43E2-AB2F-B90AF26B5E84}">
-      <p14:sectionLst xmlns:p14="http://schemas.microsoft.com/office/powerpoint/2010/main">
-        <p14:section name="Introduction" id="{41412362-99ce-0cfe-a17c-14e4e36d88be}">
-          <p14:sldIdLst>
-            <p14:sldId id="256"/>
-            <p14:sldId id="257"/>
-          </p14:sldIdLst>
-        </p14:section>
-        <p14:section name="1. Structured Outputs" id="{2f71eb2e-bcb1-da90-b77e-fd887024beb9}">
-          <p14:sldIdLst>
-            <p14:sldId id="258"/>
-            <p14:sldId id="259"/>
-            <p14:sldId id="260"/>
-          </p14:sldIdLst>
-        </p14:section>
-        <p14:section name="2. Pydantic Validation" id="{d8951670-9f91-0a4a-7eaf-b46798d3f902}">
-          <p14:sldIdLst>
-            <p14:sldId id="261"/>
-            <p14:sldId id="262"/>
-          </p14:sldIdLst>
-        </p14:section>
-        <p14:section name="3. Function Calling &amp; Tool Use" id="{1de3609e-2bbb-365c-f89b-55207f91dcc4}">
-          <p14:sldIdLst>
-            <p14:sldId id="263"/>
-            <p14:sldId id="264"/>
-            <p14:sldId id="265"/>
-          </p14:sldIdLst>
-        </p14:section>
-        <p14:section name="4. Safe Design &amp; Error Handling" id="{b156c6eb-f06c-efae-1fec-bde3dd735d5f}">
-          <p14:sldIdLst>
-            <p14:sldId id="266"/>
-            <p14:sldId id="267"/>
-            <p14:sldId id="268"/>
-            <p14:sldId id="269"/>
-          </p14:sldIdLst>
-        </p14:section>
-        <p14:section name="Wrap-up" id="{59c6571c-7d50-a0ae-f479-88d5aca1b556}">
-          <p14:sldIdLst>
-            <p14:sldId id="270"/>
-            <p14:sldId id="271"/>
-            <p14:sldId id="272"/>
-            <p14:sldId id="273"/>
-          </p14:sldIdLst>
-        </p14:section>
-      </p14:sectionLst>
-    </p:ext>
     <p:ext uri="{EFAFB233-063F-42B5-8137-9DF3F51BA10A}">
       <p15:sldGuideLst xmlns:p15="http://schemas.microsoft.com/office/powerpoint/2012/main"/>
     </p:ext>

</xml_diff>